<commit_message>
Update Incentives and COVID-19 Vaccinations Replication Project ppt.pptx
</commit_message>
<xml_diff>
--- a/Replication Project/Incentives and COVID-19 Vaccinations Replication Project ppt.pptx
+++ b/Replication Project/Incentives and COVID-19 Vaccinations Replication Project ppt.pptx
@@ -122,12 +122,25 @@
 </p:presentation>
 </file>
 
-<file path=ppt/revisionInfo.xml><?xml version="1.0" encoding="utf-8"?>
-<p1510:revInfo xmlns:a="http://schemas.openxmlformats.org/drawingml/2006/main" xmlns:r="http://schemas.openxmlformats.org/officeDocument/2006/relationships" xmlns:p1510="http://schemas.microsoft.com/office/powerpoint/2015/10/main">
-  <p1510:revLst>
-    <p1510:client id="{C7BE2EF1-764B-4A79-BD19-C638061B3F93}" v="40" dt="2026-03-20T13:07:43.512"/>
-  </p1510:revLst>
-</p1510:revInfo>
+<file path=ppt/changesInfos/changesInfo1.xml><?xml version="1.0" encoding="utf-8"?>
+<pc:chgInfo xmlns:a="http://schemas.openxmlformats.org/drawingml/2006/main" xmlns:r="http://schemas.openxmlformats.org/officeDocument/2006/relationships" xmlns:ac="http://schemas.microsoft.com/office/drawing/2013/main/command" xmlns:pc="http://schemas.microsoft.com/office/powerpoint/2013/main/command">
+  <pc:docChgLst>
+    <pc:chgData name="Alan Alvarado" userId="517dc779ebbddcdf" providerId="LiveId" clId="{39E8B4CE-5C0D-480A-8585-284C13672A74}"/>
+    <pc:docChg chg="modSld sldOrd">
+      <pc:chgData name="Alan Alvarado" userId="517dc779ebbddcdf" providerId="LiveId" clId="{39E8B4CE-5C0D-480A-8585-284C13672A74}" dt="2026-04-01T10:33:03.828" v="1"/>
+      <pc:docMkLst>
+        <pc:docMk/>
+      </pc:docMkLst>
+      <pc:sldChg chg="ord">
+        <pc:chgData name="Alan Alvarado" userId="517dc779ebbddcdf" providerId="LiveId" clId="{39E8B4CE-5C0D-480A-8585-284C13672A74}" dt="2026-04-01T10:33:03.828" v="1"/>
+        <pc:sldMkLst>
+          <pc:docMk/>
+          <pc:sldMk cId="0" sldId="257"/>
+        </pc:sldMkLst>
+      </pc:sldChg>
+    </pc:docChg>
+  </pc:docChgLst>
+</pc:chgInfo>
 </file>
 
 <file path=ppt/notesMasters/notesMaster1.xml><?xml version="1.0" encoding="utf-8"?>

</xml_diff>